<commit_message>
Bring the Test Guide and Overview decks current with the tracker model
Test Guide: the minimal-import slide now lists all six content items (KoiScanTracker
automation + 5 playbooks) and both Jobs; the requirements, List-config and field-table
slides add the Core REST API prerequisite and the tracker_list / rescan_interval_hours
fields; Test 9 walks the Refresh-then-Scan flow; troubleshooting gains the empty-tracker
row. Overview deck: 'three playbooks' -> five + tracker automation, two Jobs.

All changed slides visually QA'd — no overflow. Fixes guidance that would have left a
fresh Script-Runner-only install with an empty tracker and nothing scanned.

Co-Authored-By: Claude Fable 5 <noreply@anthropic.com>
</commit_message>
<xml_diff>
--- a/docs/KOI_Content_Pack_Overview.pptx
+++ b/docs/KOI_Content_Pack_Overview.pptx
@@ -6853,7 +6853,7 @@
                 <a:ea typeface="Calibri" pitchFamily="34" charset="-122"/>
                 <a:cs typeface="Calibri" pitchFamily="34" charset="-120"/>
               </a:rPr>
-              <a:t>Three playbooks to run KOI scripts on Cortex-Agent endpoints.</a:t>
+              <a:t>Five playbooks + an automation to run KOI scripts on Cortex-Agent endpoints.</a:t>
             </a:r>
             <a:endParaRPr lang="en-US" sz="1050" dirty="0"/>
           </a:p>
@@ -7177,7 +7177,7 @@
                 <a:ea typeface="Calibri" pitchFamily="34" charset="-122"/>
                 <a:cs typeface="Calibri" pitchFamily="34" charset="-120"/>
               </a:rPr>
-              <a:t>Run KOI script packages on Cortex-Agent endpoints on a schedule, targeted by OS, group or hostname.</a:t>
+              <a:t>Run KOI script packages on Cortex-Agent endpoints on a schedule, with per-endpoint tracking so even groups over 100 are fully covered.</a:t>
             </a:r>
             <a:endParaRPr lang="en-US" sz="1100" dirty="0"/>
           </a:p>
@@ -7219,7 +7219,7 @@
                 <a:ea typeface="Calibri" pitchFamily="34" charset="-122"/>
                 <a:cs typeface="Calibri" pitchFamily="34" charset="-120"/>
               </a:rPr>
-              <a:t>Three playbooks, configured entirely through a JSON List.</a:t>
+              <a:t>Five playbooks + a tracker automation, driven by two Jobs and one JSON List.</a:t>
             </a:r>
             <a:endParaRPr lang="en-US" sz="1000" dirty="0"/>
           </a:p>

</xml_diff>